<commit_message>
Fix OOXML schema violations — effectLst ordering in rPr and spPr
Moves effectLst before a:latin in CT_TextCharacterProperties (rPr),
and after a:ln in CT_ShapeProperties (spPr), per OOXML spec ordering.
Fixes file not opening on strict parsers (mobile Office apps).

https://claude.ai/code/session_01RtWp3mnBQhLy8aDjuXtnAW
</commit_message>
<xml_diff>
--- a/avengers_doomsday.pptx
+++ b/avengers_doomsday.pptx
@@ -3542,7 +3542,6 @@
                 <a:solidFill>
                   <a:srgbClr val="E8923A"/>
                 </a:solidFill>
-                <a:latin typeface="Impact"/>
                 <a:effectLst>
                   <a:glow rad="127000">
                     <a:srgbClr val="E8923A">
@@ -3550,6 +3549,7 @@
                     </a:srgbClr>
                   </a:glow>
                 </a:effectLst>
+                <a:latin typeface="Impact"/>
               </a:rPr>
               <a:t>⚡ A ⚡</a:t>
             </a:r>
@@ -3584,7 +3584,6 @@
                 <a:solidFill>
                   <a:srgbClr val="FFFFFF"/>
                 </a:solidFill>
-                <a:latin typeface="Impact"/>
                 <a:effectLst>
                   <a:glow rad="127000">
                     <a:srgbClr val="E8923A">
@@ -3592,6 +3591,7 @@
                     </a:srgbClr>
                   </a:glow>
                 </a:effectLst>
+                <a:latin typeface="Impact"/>
               </a:rPr>
               <a:t>AVENGERS: DOOMSDAY</a:t>
             </a:r>
@@ -3997,7 +3997,6 @@
                 <a:solidFill>
                   <a:srgbClr val="FFFFFF"/>
                 </a:solidFill>
-                <a:latin typeface="Impact"/>
                 <a:effectLst>
                   <a:glow rad="101600">
                     <a:srgbClr val="E8923A">
@@ -4005,6 +4004,7 @@
                     </a:srgbClr>
                   </a:glow>
                 </a:effectLst>
+                <a:latin typeface="Impact"/>
               </a:rPr>
               <a:t>THE THUNDERBOLTS</a:t>
             </a:r>
@@ -4112,7 +4112,7 @@
             </a:solidFill>
           </a:ln>
           <a:effectLst>
-            <a:outerShdw blurRad="355600" dist="63500" dir="8100000" algn="tl" rotWithShape="0">
+            <a:outerShdw blurRad="355600" dist="63500" dir="8100000" rotWithShape="0">
               <a:srgbClr val="000000">
                 <a:alpha val="75000"/>
               </a:srgbClr>
@@ -4363,7 +4363,7 @@
             </a:solidFill>
           </a:ln>
           <a:effectLst>
-            <a:outerShdw blurRad="355600" dist="63500" dir="8100000" algn="tl" rotWithShape="0">
+            <a:outerShdw blurRad="355600" dist="63500" dir="8100000" rotWithShape="0">
               <a:srgbClr val="000000">
                 <a:alpha val="75000"/>
               </a:srgbClr>
@@ -4614,7 +4614,7 @@
             </a:solidFill>
           </a:ln>
           <a:effectLst>
-            <a:outerShdw blurRad="355600" dist="63500" dir="8100000" algn="tl" rotWithShape="0">
+            <a:outerShdw blurRad="355600" dist="63500" dir="8100000" rotWithShape="0">
               <a:srgbClr val="000000">
                 <a:alpha val="75000"/>
               </a:srgbClr>
@@ -4865,7 +4865,7 @@
             </a:solidFill>
           </a:ln>
           <a:effectLst>
-            <a:outerShdw blurRad="355600" dist="63500" dir="8100000" algn="tl" rotWithShape="0">
+            <a:outerShdw blurRad="355600" dist="63500" dir="8100000" rotWithShape="0">
               <a:srgbClr val="000000">
                 <a:alpha val="75000"/>
               </a:srgbClr>
@@ -5116,7 +5116,7 @@
             </a:solidFill>
           </a:ln>
           <a:effectLst>
-            <a:outerShdw blurRad="355600" dist="63500" dir="8100000" algn="tl" rotWithShape="0">
+            <a:outerShdw blurRad="355600" dist="63500" dir="8100000" rotWithShape="0">
               <a:srgbClr val="000000">
                 <a:alpha val="75000"/>
               </a:srgbClr>
@@ -5367,7 +5367,7 @@
             </a:solidFill>
           </a:ln>
           <a:effectLst>
-            <a:outerShdw blurRad="355600" dist="63500" dir="8100000" algn="tl" rotWithShape="0">
+            <a:outerShdw blurRad="355600" dist="63500" dir="8100000" rotWithShape="0">
               <a:srgbClr val="000000">
                 <a:alpha val="75000"/>
               </a:srgbClr>
@@ -5834,7 +5834,6 @@
                 <a:solidFill>
                   <a:srgbClr val="FFFFFF"/>
                 </a:solidFill>
-                <a:latin typeface="Impact"/>
                 <a:effectLst>
                   <a:glow rad="101600">
                     <a:srgbClr val="E8923A">
@@ -5842,6 +5841,7 @@
                     </a:srgbClr>
                   </a:glow>
                 </a:effectLst>
+                <a:latin typeface="Impact"/>
               </a:rPr>
               <a:t>RELEASE DATE</a:t>
             </a:r>
@@ -5962,7 +5962,6 @@
                 <a:solidFill>
                   <a:srgbClr val="E8923A"/>
                 </a:solidFill>
-                <a:latin typeface="Impact"/>
                 <a:effectLst>
                   <a:glow rad="152400">
                     <a:srgbClr val="E8923A">
@@ -5970,6 +5969,7 @@
                     </a:srgbClr>
                   </a:glow>
                 </a:effectLst>
+                <a:latin typeface="Impact"/>
               </a:rPr>
               <a:t>DECEMBER 18, 2026</a:t>
             </a:r>
@@ -5999,7 +5999,7 @@
             </a:solidFill>
           </a:ln>
           <a:effectLst>
-            <a:outerShdw blurRad="355600" dist="63500" dir="8100000" algn="tl" rotWithShape="0">
+            <a:outerShdw blurRad="355600" dist="63500" dir="8100000" rotWithShape="0">
               <a:srgbClr val="000000">
                 <a:alpha val="75000"/>
               </a:srgbClr>
@@ -6200,7 +6200,7 @@
             </a:solidFill>
           </a:ln>
           <a:effectLst>
-            <a:outerShdw blurRad="355600" dist="63500" dir="8100000" algn="tl" rotWithShape="0">
+            <a:outerShdw blurRad="355600" dist="63500" dir="8100000" rotWithShape="0">
               <a:srgbClr val="000000">
                 <a:alpha val="75000"/>
               </a:srgbClr>
@@ -6619,7 +6619,6 @@
                 <a:solidFill>
                   <a:srgbClr val="FFFFFF"/>
                 </a:solidFill>
-                <a:latin typeface="Impact"/>
                 <a:effectLst>
                   <a:glow rad="101600">
                     <a:srgbClr val="E8923A">
@@ -6627,6 +6626,7 @@
                     </a:srgbClr>
                   </a:glow>
                 </a:effectLst>
+                <a:latin typeface="Impact"/>
               </a:rPr>
               <a:t>PHASE 6 TIMELINE</a:t>
             </a:r>
@@ -7288,7 +7288,6 @@
                 <a:solidFill>
                   <a:srgbClr val="E8923A"/>
                 </a:solidFill>
-                <a:latin typeface="Impact"/>
                 <a:effectLst>
                   <a:glow rad="101600">
                     <a:srgbClr val="E8923A">
@@ -7296,6 +7295,7 @@
                     </a:srgbClr>
                   </a:glow>
                 </a:effectLst>
+                <a:latin typeface="Impact"/>
               </a:rPr>
               <a:t>AVENGERS:
 DOOMSDAY ★</a:t>
@@ -7781,7 +7781,6 @@
                 <a:solidFill>
                   <a:srgbClr val="FFFFFF"/>
                 </a:solidFill>
-                <a:latin typeface="Impact"/>
                 <a:effectLst>
                   <a:glow rad="101600">
                     <a:srgbClr val="E8923A">
@@ -7789,6 +7788,7 @@
                     </a:srgbClr>
                   </a:glow>
                 </a:effectLst>
+                <a:latin typeface="Impact"/>
               </a:rPr>
               <a:t>BY THE NUMBERS</a:t>
             </a:r>
@@ -7861,7 +7861,7 @@
             </a:solidFill>
           </a:ln>
           <a:effectLst>
-            <a:outerShdw blurRad="355600" dist="63500" dir="8100000" algn="tl" rotWithShape="0">
+            <a:outerShdw blurRad="355600" dist="63500" dir="8100000" rotWithShape="0">
               <a:srgbClr val="000000">
                 <a:alpha val="75000"/>
               </a:srgbClr>
@@ -7918,7 +7918,6 @@
                 <a:solidFill>
                   <a:srgbClr val="E8923A"/>
                 </a:solidFill>
-                <a:latin typeface="Impact"/>
                 <a:effectLst>
                   <a:glow rad="101600">
                     <a:srgbClr val="E8923A">
@@ -7926,6 +7925,7 @@
                     </a:srgbClr>
                   </a:glow>
                 </a:effectLst>
+                <a:latin typeface="Impact"/>
               </a:rPr>
               <a:t>39</a:t>
             </a:r>
@@ -7991,7 +7991,7 @@
             </a:solidFill>
           </a:ln>
           <a:effectLst>
-            <a:outerShdw blurRad="355600" dist="63500" dir="8100000" algn="tl" rotWithShape="0">
+            <a:outerShdw blurRad="355600" dist="63500" dir="8100000" rotWithShape="0">
               <a:srgbClr val="000000">
                 <a:alpha val="75000"/>
               </a:srgbClr>
@@ -8048,7 +8048,6 @@
                 <a:solidFill>
                   <a:srgbClr val="E8923A"/>
                 </a:solidFill>
-                <a:latin typeface="Impact"/>
                 <a:effectLst>
                   <a:glow rad="101600">
                     <a:srgbClr val="E8923A">
@@ -8056,6 +8055,7 @@
                     </a:srgbClr>
                   </a:glow>
                 </a:effectLst>
+                <a:latin typeface="Impact"/>
               </a:rPr>
               <a:t>$2.79B</a:t>
             </a:r>
@@ -8121,7 +8121,7 @@
             </a:solidFill>
           </a:ln>
           <a:effectLst>
-            <a:outerShdw blurRad="355600" dist="63500" dir="8100000" algn="tl" rotWithShape="0">
+            <a:outerShdw blurRad="355600" dist="63500" dir="8100000" rotWithShape="0">
               <a:srgbClr val="000000">
                 <a:alpha val="75000"/>
               </a:srgbClr>
@@ -8178,7 +8178,6 @@
                 <a:solidFill>
                   <a:srgbClr val="E8923A"/>
                 </a:solidFill>
-                <a:latin typeface="Impact"/>
                 <a:effectLst>
                   <a:glow rad="101600">
                     <a:srgbClr val="E8923A">
@@ -8186,6 +8185,7 @@
                     </a:srgbClr>
                   </a:glow>
                 </a:effectLst>
+                <a:latin typeface="Impact"/>
               </a:rPr>
               <a:t>4</a:t>
             </a:r>
@@ -8251,7 +8251,7 @@
             </a:solidFill>
           </a:ln>
           <a:effectLst>
-            <a:outerShdw blurRad="355600" dist="63500" dir="8100000" algn="tl" rotWithShape="0">
+            <a:outerShdw blurRad="355600" dist="63500" dir="8100000" rotWithShape="0">
               <a:srgbClr val="000000">
                 <a:alpha val="75000"/>
               </a:srgbClr>
@@ -8308,7 +8308,6 @@
                 <a:solidFill>
                   <a:srgbClr val="E8923A"/>
                 </a:solidFill>
-                <a:latin typeface="Impact"/>
                 <a:effectLst>
                   <a:glow rad="101600">
                     <a:srgbClr val="E8923A">
@@ -8316,6 +8315,7 @@
                     </a:srgbClr>
                   </a:glow>
                 </a:effectLst>
+                <a:latin typeface="Impact"/>
               </a:rPr>
               <a:t>3</a:t>
             </a:r>
@@ -8381,7 +8381,7 @@
             </a:solidFill>
           </a:ln>
           <a:effectLst>
-            <a:outerShdw blurRad="355600" dist="63500" dir="8100000" algn="tl" rotWithShape="0">
+            <a:outerShdw blurRad="355600" dist="63500" dir="8100000" rotWithShape="0">
               <a:srgbClr val="000000">
                 <a:alpha val="75000"/>
               </a:srgbClr>
@@ -8438,7 +8438,6 @@
                 <a:solidFill>
                   <a:srgbClr val="E8923A"/>
                 </a:solidFill>
-                <a:latin typeface="Impact"/>
                 <a:effectLst>
                   <a:glow rad="101600">
                     <a:srgbClr val="E8923A">
@@ -8446,6 +8445,7 @@
                     </a:srgbClr>
                   </a:glow>
                 </a:effectLst>
+                <a:latin typeface="Impact"/>
               </a:rPr>
               <a:t>2026</a:t>
             </a:r>
@@ -8511,7 +8511,7 @@
             </a:solidFill>
           </a:ln>
           <a:effectLst>
-            <a:outerShdw blurRad="355600" dist="63500" dir="8100000" algn="tl" rotWithShape="0">
+            <a:outerShdw blurRad="355600" dist="63500" dir="8100000" rotWithShape="0">
               <a:srgbClr val="000000">
                 <a:alpha val="75000"/>
               </a:srgbClr>
@@ -8568,7 +8568,6 @@
                 <a:solidFill>
                   <a:srgbClr val="E8923A"/>
                 </a:solidFill>
-                <a:latin typeface="Impact"/>
                 <a:effectLst>
                   <a:glow rad="101600">
                     <a:srgbClr val="E8923A">
@@ -8576,6 +8575,7 @@
                     </a:srgbClr>
                   </a:glow>
                 </a:effectLst>
+                <a:latin typeface="Impact"/>
               </a:rPr>
               <a:t>1</a:t>
             </a:r>
@@ -8942,7 +8942,7 @@
             </a:solidFill>
           </a:ln>
           <a:effectLst>
-            <a:outerShdw blurRad="355600" dist="63500" dir="8100000" algn="tl" rotWithShape="0">
+            <a:outerShdw blurRad="355600" dist="63500" dir="8100000" rotWithShape="0">
               <a:srgbClr val="000000">
                 <a:alpha val="75000"/>
               </a:srgbClr>
@@ -8999,7 +8999,6 @@
                 <a:solidFill>
                   <a:srgbClr val="FFFFFF"/>
                 </a:solidFill>
-                <a:latin typeface="Impact"/>
                 <a:effectLst>
                   <a:glow rad="101600">
                     <a:srgbClr val="E8923A">
@@ -9007,6 +9006,7 @@
                     </a:srgbClr>
                   </a:glow>
                 </a:effectLst>
+                <a:latin typeface="Impact"/>
               </a:rPr>
               <a:t>WHY IT MATTERS</a:t>
             </a:r>
@@ -9114,7 +9114,7 @@
             </a:solidFill>
           </a:ln>
           <a:effectLst>
-            <a:outerShdw blurRad="355600" dist="63500" dir="8100000" algn="tl" rotWithShape="0">
+            <a:outerShdw blurRad="355600" dist="63500" dir="8100000" rotWithShape="0">
               <a:srgbClr val="000000">
                 <a:alpha val="75000"/>
               </a:srgbClr>
@@ -9237,7 +9237,7 @@
             </a:solidFill>
           </a:ln>
           <a:effectLst>
-            <a:outerShdw blurRad="355600" dist="63500" dir="8100000" algn="tl" rotWithShape="0">
+            <a:outerShdw blurRad="355600" dist="63500" dir="8100000" rotWithShape="0">
               <a:srgbClr val="000000">
                 <a:alpha val="75000"/>
               </a:srgbClr>
@@ -9360,7 +9360,7 @@
             </a:solidFill>
           </a:ln>
           <a:effectLst>
-            <a:outerShdw blurRad="355600" dist="63500" dir="8100000" algn="tl" rotWithShape="0">
+            <a:outerShdw blurRad="355600" dist="63500" dir="8100000" rotWithShape="0">
               <a:srgbClr val="000000">
                 <a:alpha val="75000"/>
               </a:srgbClr>
@@ -9871,7 +9871,6 @@
                 <a:solidFill>
                   <a:srgbClr val="FFFFFF"/>
                 </a:solidFill>
-                <a:latin typeface="Impact"/>
                 <a:effectLst>
                   <a:glow rad="177800">
                     <a:srgbClr val="E8923A">
@@ -9879,6 +9878,7 @@
                     </a:srgbClr>
                   </a:glow>
                 </a:effectLst>
+                <a:latin typeface="Impact"/>
               </a:rPr>
               <a:t>DOOM IS COMING.</a:t>
             </a:r>
@@ -10244,7 +10244,7 @@
             </a:solidFill>
           </a:ln>
           <a:effectLst>
-            <a:outerShdw blurRad="355600" dist="63500" dir="8100000" algn="tl" rotWithShape="0">
+            <a:outerShdw blurRad="355600" dist="63500" dir="8100000" rotWithShape="0">
               <a:srgbClr val="000000">
                 <a:alpha val="75000"/>
               </a:srgbClr>
@@ -10301,7 +10301,6 @@
                 <a:solidFill>
                   <a:srgbClr val="FFFFFF"/>
                 </a:solidFill>
-                <a:latin typeface="Impact"/>
                 <a:effectLst>
                   <a:glow rad="101600">
                     <a:srgbClr val="E8923A">
@@ -10309,6 +10308,7 @@
                     </a:srgbClr>
                   </a:glow>
                 </a:effectLst>
+                <a:latin typeface="Impact"/>
               </a:rPr>
               <a:t>WHAT IS THIS FILM?</a:t>
             </a:r>
@@ -11105,7 +11105,7 @@
             </a:solidFill>
           </a:ln>
           <a:effectLst>
-            <a:outerShdw blurRad="355600" dist="63500" dir="8100000" algn="tl" rotWithShape="0">
+            <a:outerShdw blurRad="355600" dist="63500" dir="8100000" rotWithShape="0">
               <a:srgbClr val="000000">
                 <a:alpha val="75000"/>
               </a:srgbClr>
@@ -11291,7 +11291,6 @@
                 <a:solidFill>
                   <a:srgbClr val="C02020"/>
                 </a:solidFill>
-                <a:latin typeface="Impact"/>
                 <a:effectLst>
                   <a:glow rad="127000">
                     <a:srgbClr val="C02020">
@@ -11299,6 +11298,7 @@
                     </a:srgbClr>
                   </a:glow>
                 </a:effectLst>
+                <a:latin typeface="Impact"/>
               </a:rPr>
               <a:t>⚔</a:t>
             </a:r>
@@ -11333,7 +11333,6 @@
                 <a:solidFill>
                   <a:srgbClr val="FFFFFF"/>
                 </a:solidFill>
-                <a:latin typeface="Impact"/>
                 <a:effectLst>
                   <a:glow rad="101600">
                     <a:srgbClr val="C02020">
@@ -11341,6 +11340,7 @@
                     </a:srgbClr>
                   </a:glow>
                 </a:effectLst>
+                <a:latin typeface="Impact"/>
               </a:rPr>
               <a:t>VICTOR VON DOOM</a:t>
             </a:r>
@@ -11448,7 +11448,7 @@
             </a:solidFill>
           </a:ln>
           <a:effectLst>
-            <a:outerShdw blurRad="355600" dist="63500" dir="8100000" algn="tl" rotWithShape="0">
+            <a:outerShdw blurRad="355600" dist="63500" dir="8100000" rotWithShape="0">
               <a:srgbClr val="000000">
                 <a:alpha val="75000"/>
               </a:srgbClr>
@@ -11571,7 +11571,7 @@
             </a:solidFill>
           </a:ln>
           <a:effectLst>
-            <a:outerShdw blurRad="355600" dist="63500" dir="8100000" algn="tl" rotWithShape="0">
+            <a:outerShdw blurRad="355600" dist="63500" dir="8100000" rotWithShape="0">
               <a:srgbClr val="000000">
                 <a:alpha val="75000"/>
               </a:srgbClr>
@@ -11694,7 +11694,7 @@
             </a:solidFill>
           </a:ln>
           <a:effectLst>
-            <a:outerShdw blurRad="355600" dist="63500" dir="8100000" algn="tl" rotWithShape="0">
+            <a:outerShdw blurRad="355600" dist="63500" dir="8100000" rotWithShape="0">
               <a:srgbClr val="000000">
                 <a:alpha val="75000"/>
               </a:srgbClr>
@@ -12118,7 +12118,7 @@
             </a:solidFill>
           </a:ln>
           <a:effectLst>
-            <a:outerShdw blurRad="355600" dist="63500" dir="8100000" algn="tl" rotWithShape="0">
+            <a:outerShdw blurRad="355600" dist="63500" dir="8100000" rotWithShape="0">
               <a:srgbClr val="000000">
                 <a:alpha val="75000"/>
               </a:srgbClr>
@@ -12283,7 +12283,7 @@
             </a:solidFill>
           </a:ln>
           <a:effectLst>
-            <a:outerShdw blurRad="355600" dist="63500" dir="8100000" algn="tl" rotWithShape="0">
+            <a:outerShdw blurRad="355600" dist="63500" dir="8100000" rotWithShape="0">
               <a:srgbClr val="000000">
                 <a:alpha val="75000"/>
               </a:srgbClr>
@@ -12340,7 +12340,6 @@
                 <a:solidFill>
                   <a:srgbClr val="FFFFFF"/>
                 </a:solidFill>
-                <a:latin typeface="Impact"/>
                 <a:effectLst>
                   <a:glow rad="101600">
                     <a:srgbClr val="E8923A">
@@ -12348,6 +12347,7 @@
                     </a:srgbClr>
                   </a:glow>
                 </a:effectLst>
+                <a:latin typeface="Impact"/>
               </a:rPr>
               <a:t>RDJ: IRON MAN → IRON DOOM</a:t>
             </a:r>
@@ -13097,7 +13097,6 @@
                 <a:solidFill>
                   <a:srgbClr val="FFFFFF"/>
                 </a:solidFill>
-                <a:latin typeface="Impact"/>
                 <a:effectLst>
                   <a:glow rad="101600">
                     <a:srgbClr val="E8923A">
@@ -13105,6 +13104,7 @@
                     </a:srgbClr>
                   </a:glow>
                 </a:effectLst>
+                <a:latin typeface="Impact"/>
               </a:rPr>
               <a:t>THE RUSSO BROTHERS</a:t>
             </a:r>
@@ -13177,7 +13177,7 @@
             </a:solidFill>
           </a:ln>
           <a:effectLst>
-            <a:outerShdw blurRad="355600" dist="63500" dir="8100000" algn="tl" rotWithShape="0">
+            <a:outerShdw blurRad="355600" dist="63500" dir="8100000" rotWithShape="0">
               <a:srgbClr val="000000">
                 <a:alpha val="75000"/>
               </a:srgbClr>
@@ -13386,7 +13386,7 @@
             </a:solidFill>
           </a:ln>
           <a:effectLst>
-            <a:outerShdw blurRad="355600" dist="63500" dir="8100000" algn="tl" rotWithShape="0">
+            <a:outerShdw blurRad="355600" dist="63500" dir="8100000" rotWithShape="0">
               <a:srgbClr val="000000">
                 <a:alpha val="75000"/>
               </a:srgbClr>
@@ -13438,7 +13438,7 @@
             </a:solidFill>
           </a:ln>
           <a:effectLst>
-            <a:outerShdw blurRad="355600" dist="63500" dir="8100000" algn="tl" rotWithShape="0">
+            <a:outerShdw blurRad="355600" dist="63500" dir="8100000" rotWithShape="0">
               <a:srgbClr val="000000">
                 <a:alpha val="75000"/>
               </a:srgbClr>
@@ -13495,7 +13495,6 @@
                 <a:solidFill>
                   <a:srgbClr val="E8923A"/>
                 </a:solidFill>
-                <a:latin typeface="Impact"/>
                 <a:effectLst>
                   <a:glow rad="101600">
                     <a:srgbClr val="E8923A">
@@ -13503,6 +13502,7 @@
                     </a:srgbClr>
                   </a:glow>
                 </a:effectLst>
+                <a:latin typeface="Impact"/>
               </a:rPr>
               <a:t>4</a:t>
             </a:r>
@@ -13567,7 +13567,7 @@
             </a:solidFill>
           </a:ln>
           <a:effectLst>
-            <a:outerShdw blurRad="355600" dist="63500" dir="8100000" algn="tl" rotWithShape="0">
+            <a:outerShdw blurRad="355600" dist="63500" dir="8100000" rotWithShape="0">
               <a:srgbClr val="000000">
                 <a:alpha val="75000"/>
               </a:srgbClr>
@@ -13624,7 +13624,6 @@
                 <a:solidFill>
                   <a:srgbClr val="E8923A"/>
                 </a:solidFill>
-                <a:latin typeface="Impact"/>
                 <a:effectLst>
                   <a:glow rad="101600">
                     <a:srgbClr val="E8923A">
@@ -13632,6 +13631,7 @@
                     </a:srgbClr>
                   </a:glow>
                 </a:effectLst>
+                <a:latin typeface="Impact"/>
               </a:rPr>
               <a:t>$2.79B</a:t>
             </a:r>
@@ -13696,7 +13696,7 @@
             </a:solidFill>
           </a:ln>
           <a:effectLst>
-            <a:outerShdw blurRad="355600" dist="63500" dir="8100000" algn="tl" rotWithShape="0">
+            <a:outerShdw blurRad="355600" dist="63500" dir="8100000" rotWithShape="0">
               <a:srgbClr val="000000">
                 <a:alpha val="75000"/>
               </a:srgbClr>
@@ -13753,7 +13753,6 @@
                 <a:solidFill>
                   <a:srgbClr val="E8923A"/>
                 </a:solidFill>
-                <a:latin typeface="Impact"/>
                 <a:effectLst>
                   <a:glow rad="101600">
                     <a:srgbClr val="E8923A">
@@ -13761,6 +13760,7 @@
                     </a:srgbClr>
                   </a:glow>
                 </a:effectLst>
+                <a:latin typeface="Impact"/>
               </a:rPr>
               <a:t>#1</a:t>
             </a:r>
@@ -13826,7 +13826,7 @@
             </a:solidFill>
           </a:ln>
           <a:effectLst>
-            <a:outerShdw blurRad="355600" dist="63500" dir="8100000" algn="tl" rotWithShape="0">
+            <a:outerShdw blurRad="355600" dist="63500" dir="8100000" rotWithShape="0">
               <a:srgbClr val="000000">
                 <a:alpha val="75000"/>
               </a:srgbClr>
@@ -13883,7 +13883,6 @@
                 <a:solidFill>
                   <a:srgbClr val="E8923A"/>
                 </a:solidFill>
-                <a:latin typeface="Impact"/>
                 <a:effectLst>
                   <a:glow rad="101600">
                     <a:srgbClr val="E8923A">
@@ -13891,6 +13890,7 @@
                     </a:srgbClr>
                   </a:glow>
                 </a:effectLst>
+                <a:latin typeface="Impact"/>
               </a:rPr>
               <a:t>2027</a:t>
             </a:r>
@@ -14172,7 +14172,6 @@
                 <a:solidFill>
                   <a:srgbClr val="FFFFFF"/>
                 </a:solidFill>
-                <a:latin typeface="Impact"/>
                 <a:effectLst>
                   <a:glow rad="101600">
                     <a:srgbClr val="E8923A">
@@ -14180,6 +14179,7 @@
                     </a:srgbClr>
                   </a:glow>
                 </a:effectLst>
+                <a:latin typeface="Impact"/>
               </a:rPr>
               <a:t>THE HEROES</a:t>
             </a:r>
@@ -14252,7 +14252,7 @@
             </a:solidFill>
           </a:ln>
           <a:effectLst>
-            <a:outerShdw blurRad="355600" dist="63500" dir="8100000" algn="tl" rotWithShape="0">
+            <a:outerShdw blurRad="355600" dist="63500" dir="8100000" rotWithShape="0">
               <a:srgbClr val="000000">
                 <a:alpha val="75000"/>
               </a:srgbClr>
@@ -14503,7 +14503,7 @@
             </a:solidFill>
           </a:ln>
           <a:effectLst>
-            <a:outerShdw blurRad="355600" dist="63500" dir="8100000" algn="tl" rotWithShape="0">
+            <a:outerShdw blurRad="355600" dist="63500" dir="8100000" rotWithShape="0">
               <a:srgbClr val="000000">
                 <a:alpha val="75000"/>
               </a:srgbClr>
@@ -14754,7 +14754,7 @@
             </a:solidFill>
           </a:ln>
           <a:effectLst>
-            <a:outerShdw blurRad="355600" dist="63500" dir="8100000" algn="tl" rotWithShape="0">
+            <a:outerShdw blurRad="355600" dist="63500" dir="8100000" rotWithShape="0">
               <a:srgbClr val="000000">
                 <a:alpha val="75000"/>
               </a:srgbClr>
@@ -15005,7 +15005,7 @@
             </a:solidFill>
           </a:ln>
           <a:effectLst>
-            <a:outerShdw blurRad="355600" dist="63500" dir="8100000" algn="tl" rotWithShape="0">
+            <a:outerShdw blurRad="355600" dist="63500" dir="8100000" rotWithShape="0">
               <a:srgbClr val="000000">
                 <a:alpha val="75000"/>
               </a:srgbClr>
@@ -15256,7 +15256,7 @@
             </a:solidFill>
           </a:ln>
           <a:effectLst>
-            <a:outerShdw blurRad="355600" dist="63500" dir="8100000" algn="tl" rotWithShape="0">
+            <a:outerShdw blurRad="355600" dist="63500" dir="8100000" rotWithShape="0">
               <a:srgbClr val="000000">
                 <a:alpha val="75000"/>
               </a:srgbClr>
@@ -15507,7 +15507,7 @@
             </a:solidFill>
           </a:ln>
           <a:effectLst>
-            <a:outerShdw blurRad="355600" dist="63500" dir="8100000" algn="tl" rotWithShape="0">
+            <a:outerShdw blurRad="355600" dist="63500" dir="8100000" rotWithShape="0">
               <a:srgbClr val="000000">
                 <a:alpha val="75000"/>
               </a:srgbClr>
@@ -15758,7 +15758,7 @@
             </a:solidFill>
           </a:ln>
           <a:effectLst>
-            <a:outerShdw blurRad="355600" dist="63500" dir="8100000" algn="tl" rotWithShape="0">
+            <a:outerShdw blurRad="355600" dist="63500" dir="8100000" rotWithShape="0">
               <a:srgbClr val="000000">
                 <a:alpha val="75000"/>
               </a:srgbClr>
@@ -16009,7 +16009,7 @@
             </a:solidFill>
           </a:ln>
           <a:effectLst>
-            <a:outerShdw blurRad="355600" dist="63500" dir="8100000" algn="tl" rotWithShape="0">
+            <a:outerShdw blurRad="355600" dist="63500" dir="8100000" rotWithShape="0">
               <a:srgbClr val="000000">
                 <a:alpha val="75000"/>
               </a:srgbClr>
@@ -16260,7 +16260,7 @@
             </a:solidFill>
           </a:ln>
           <a:effectLst>
-            <a:outerShdw blurRad="355600" dist="63500" dir="8100000" algn="tl" rotWithShape="0">
+            <a:outerShdw blurRad="355600" dist="63500" dir="8100000" rotWithShape="0">
               <a:srgbClr val="000000">
                 <a:alpha val="75000"/>
               </a:srgbClr>
@@ -16812,7 +16812,7 @@
             </a:solidFill>
           </a:ln>
           <a:effectLst>
-            <a:outerShdw blurRad="355600" dist="63500" dir="8100000" algn="tl" rotWithShape="0">
+            <a:outerShdw blurRad="355600" dist="63500" dir="8100000" rotWithShape="0">
               <a:srgbClr val="000000">
                 <a:alpha val="75000"/>
               </a:srgbClr>
@@ -16998,7 +16998,6 @@
                 <a:solidFill>
                   <a:srgbClr val="FFFFFF"/>
                 </a:solidFill>
-                <a:latin typeface="Impact"/>
                 <a:effectLst>
                   <a:glow rad="101600">
                     <a:srgbClr val="D4AF37">
@@ -17006,6 +17005,7 @@
                     </a:srgbClr>
                   </a:glow>
                 </a:effectLst>
+                <a:latin typeface="Impact"/>
               </a:rPr>
               <a:t>THE FANTASTIC FOUR</a:t>
             </a:r>
@@ -17148,7 +17148,7 @@
             </a:solidFill>
           </a:ln>
           <a:effectLst>
-            <a:outerShdw blurRad="355600" dist="63500" dir="8100000" algn="tl" rotWithShape="0">
+            <a:outerShdw blurRad="355600" dist="63500" dir="8100000" rotWithShape="0">
               <a:srgbClr val="000000">
                 <a:alpha val="75000"/>
               </a:srgbClr>
@@ -17313,7 +17313,7 @@
             </a:solidFill>
           </a:ln>
           <a:effectLst>
-            <a:outerShdw blurRad="355600" dist="63500" dir="8100000" algn="tl" rotWithShape="0">
+            <a:outerShdw blurRad="355600" dist="63500" dir="8100000" rotWithShape="0">
               <a:srgbClr val="000000">
                 <a:alpha val="75000"/>
               </a:srgbClr>
@@ -17478,7 +17478,7 @@
             </a:solidFill>
           </a:ln>
           <a:effectLst>
-            <a:outerShdw blurRad="355600" dist="63500" dir="8100000" algn="tl" rotWithShape="0">
+            <a:outerShdw blurRad="355600" dist="63500" dir="8100000" rotWithShape="0">
               <a:srgbClr val="000000">
                 <a:alpha val="75000"/>
               </a:srgbClr>
@@ -17643,7 +17643,7 @@
             </a:solidFill>
           </a:ln>
           <a:effectLst>
-            <a:outerShdw blurRad="355600" dist="63500" dir="8100000" algn="tl" rotWithShape="0">
+            <a:outerShdw blurRad="355600" dist="63500" dir="8100000" rotWithShape="0">
               <a:srgbClr val="000000">
                 <a:alpha val="75000"/>
               </a:srgbClr>
@@ -18109,7 +18109,7 @@
             </a:solidFill>
           </a:ln>
           <a:effectLst>
-            <a:outerShdw blurRad="355600" dist="63500" dir="8100000" algn="tl" rotWithShape="0">
+            <a:outerShdw blurRad="355600" dist="63500" dir="8100000" rotWithShape="0">
               <a:srgbClr val="000000">
                 <a:alpha val="75000"/>
               </a:srgbClr>
@@ -18295,7 +18295,6 @@
                 <a:solidFill>
                   <a:srgbClr val="AB47BC"/>
                 </a:solidFill>
-                <a:latin typeface="Impact"/>
                 <a:effectLst>
                   <a:glow rad="152400">
                     <a:srgbClr val="AB47BC">
@@ -18303,6 +18302,7 @@
                     </a:srgbClr>
                   </a:glow>
                 </a:effectLst>
+                <a:latin typeface="Impact"/>
               </a:rPr>
               <a:t>X</a:t>
             </a:r>
@@ -18337,7 +18337,6 @@
                 <a:solidFill>
                   <a:srgbClr val="FFFFFF"/>
                 </a:solidFill>
-                <a:latin typeface="Impact"/>
                 <a:effectLst>
                   <a:glow rad="101600">
                     <a:srgbClr val="AB47BC">
@@ -18345,6 +18344,7 @@
                     </a:srgbClr>
                   </a:glow>
                 </a:effectLst>
+                <a:latin typeface="Impact"/>
               </a:rPr>
               <a:t>THE X-MEN ARRIVE</a:t>
             </a:r>
@@ -18417,7 +18417,7 @@
             </a:solidFill>
           </a:ln>
           <a:effectLst>
-            <a:outerShdw blurRad="355600" dist="63500" dir="8100000" algn="tl" rotWithShape="0">
+            <a:outerShdw blurRad="355600" dist="63500" dir="8100000" rotWithShape="0">
               <a:srgbClr val="000000">
                 <a:alpha val="75000"/>
               </a:srgbClr>
@@ -18582,7 +18582,7 @@
             </a:solidFill>
           </a:ln>
           <a:effectLst>
-            <a:outerShdw blurRad="355600" dist="63500" dir="8100000" algn="tl" rotWithShape="0">
+            <a:outerShdw blurRad="355600" dist="63500" dir="8100000" rotWithShape="0">
               <a:srgbClr val="000000">
                 <a:alpha val="75000"/>
               </a:srgbClr>
@@ -19083,7 +19083,7 @@
             </a:solidFill>
           </a:ln>
           <a:effectLst>
-            <a:outerShdw blurRad="355600" dist="63500" dir="8100000" algn="tl" rotWithShape="0">
+            <a:outerShdw blurRad="355600" dist="63500" dir="8100000" rotWithShape="0">
               <a:srgbClr val="000000">
                 <a:alpha val="75000"/>
               </a:srgbClr>
@@ -19140,7 +19140,6 @@
                 <a:solidFill>
                   <a:srgbClr val="FFFFFF"/>
                 </a:solidFill>
-                <a:latin typeface="Impact"/>
                 <a:effectLst>
                   <a:glow rad="101600">
                     <a:srgbClr val="E8923A">
@@ -19148,6 +19147,7 @@
                     </a:srgbClr>
                   </a:glow>
                 </a:effectLst>
+                <a:latin typeface="Impact"/>
               </a:rPr>
               <a:t>THE PLOT</a:t>
             </a:r>

</xml_diff>